<commit_message>
Chuyển cấu hình từ application.yml sang application.properties theo yêu cầu môn học
- application.yml -> application.properties, application-h2.yml -> application-h2.properties
  (giữ nguyên 93 + 9 khoá; đã đối chiếu bằng YamlPropertySourceLoader và PropertiesPropertySourceLoader, 0 khác biệt)
- Cập nhật chú thích trong AiEnvironmentPostProcessor, AppProperties, AiWiringTest
- Cập nhật CLAUDE.md, PLAN.md (thêm gotcha #79 về bảng mã ISO-8859-1 của .properties), HUONG_DAN_DEMO.md,
  BAO_CAO.md, SESSION_HANDOFF.md, SPEC_CHUNG.md, báo cáo Word và slide 19

Co-Authored-By: Claude Opus 5.5 <noreply@anthropic.com>
Claude-Session: https://claude.ai/code/session_013XogQ7LUdqQFBFQpnDLfN8
</commit_message>
<xml_diff>
--- a/docs/presentation/SpringAI_VectorDB_UserTracking.pptx
+++ b/docs/presentation/SpringAI_VectorDB_UserTracking.pptx
@@ -19732,7 +19732,7 @@
       </p:sp>
       <p:sp>
         <p:nvSpPr>
-          <p:cNvPr id="9" name="Code panel application.yml"/>
+          <p:cNvPr id="9" name="Code panel application.properties"/>
           <p:cNvSpPr/>
           <p:nvPr/>
         </p:nvSpPr>
@@ -19787,7 +19787,7 @@
                   <a:schemeClr val="accent5"/>
                 </a:solidFill>
               </a:rPr>
-              <a:t>application.yml</a:t>
+              <a:t>application.properties</a:t>
             </a:r>
             <a:endParaRPr lang="en-US" sz="1100" dirty="0"/>
           </a:p>
@@ -19795,7 +19795,7 @@
       </p:sp>
       <p:sp>
         <p:nvSpPr>
-          <p:cNvPr id="11" name="Code application.yml"/>
+          <p:cNvPr id="11" name="Code application.properties"/>
           <p:cNvSpPr txBox="1"/>
           <p:nvPr/>
         </p:nvSpPr>
@@ -19816,222 +19816,122 @@
           <a:p>
             <a:pPr indent="0" marL="0">
               <a:lnSpc>
-                <a:spcPts val="1400"/>
+                <a:spcPts val="1900"/>
               </a:lnSpc>
               <a:buNone/>
             </a:pPr>
             <a:r>
-              <a:rPr lang="en-US" sz="1100" dirty="0">
-                <a:solidFill>
-                  <a:srgbClr val="EFF7F5"/>
-                </a:solidFill>
-                <a:latin typeface="Courier New" pitchFamily="34" charset="0"/>
-                <a:ea typeface="Courier New" pitchFamily="34" charset="-122"/>
-                <a:cs typeface="Courier New" pitchFamily="34" charset="-120"/>
-              </a:rPr>
-              <a:t>spring:</a:t>
-            </a:r>
-            <a:endParaRPr lang="en-US" sz="1100" dirty="0"/>
+              <a:rPr lang="en-US" sz="950" dirty="0">
+                <a:solidFill>
+                  <a:srgbClr val="EFF7F5"/>
+                </a:solidFill>
+                <a:latin typeface="Courier New" pitchFamily="34" charset="0"/>
+                <a:ea typeface="Courier New" pitchFamily="34" charset="-122"/>
+                <a:cs typeface="Courier New" pitchFamily="34" charset="-120"/>
+              </a:rPr>
+              <a:t>spring.ai.openai.api-key=${GEMINI_API_KEY:}</a:t>
+            </a:r>
+            <a:endParaRPr lang="en-US" sz="950" dirty="0"/>
           </a:p>
           <a:p>
             <a:pPr indent="0" marL="0">
               <a:lnSpc>
-                <a:spcPts val="1400"/>
+                <a:spcPts val="1900"/>
               </a:lnSpc>
               <a:buNone/>
             </a:pPr>
             <a:r>
-              <a:rPr lang="en-US" sz="1100" dirty="0">
-                <a:solidFill>
-                  <a:srgbClr val="EFF7F5"/>
-                </a:solidFill>
-                <a:latin typeface="Courier New" pitchFamily="34" charset="0"/>
-                <a:ea typeface="Courier New" pitchFamily="34" charset="-122"/>
-                <a:cs typeface="Courier New" pitchFamily="34" charset="-120"/>
-              </a:rPr>
-              <a:t>  ai:</a:t>
-            </a:r>
-            <a:endParaRPr lang="en-US" sz="1100" dirty="0"/>
+              <a:rPr lang="en-US" sz="950" dirty="0">
+                <a:solidFill>
+                  <a:srgbClr val="EFF7F5"/>
+                </a:solidFill>
+                <a:latin typeface="Courier New" pitchFamily="34" charset="0"/>
+                <a:ea typeface="Courier New" pitchFamily="34" charset="-122"/>
+                <a:cs typeface="Courier New" pitchFamily="34" charset="-120"/>
+              </a:rPr>
+              <a:t>spring.ai.openai.base-url=https://generativelanguage.googleapis.com</a:t>
+            </a:r>
+            <a:endParaRPr lang="en-US" sz="950" dirty="0"/>
           </a:p>
           <a:p>
             <a:pPr indent="0" marL="0">
               <a:lnSpc>
-                <a:spcPts val="1400"/>
+                <a:spcPts val="1900"/>
               </a:lnSpc>
               <a:buNone/>
             </a:pPr>
             <a:r>
-              <a:rPr lang="en-US" sz="1100" dirty="0">
-                <a:solidFill>
-                  <a:srgbClr val="EFF7F5"/>
-                </a:solidFill>
-                <a:latin typeface="Courier New" pitchFamily="34" charset="0"/>
-                <a:ea typeface="Courier New" pitchFamily="34" charset="-122"/>
-                <a:cs typeface="Courier New" pitchFamily="34" charset="-120"/>
-              </a:rPr>
-              <a:t>    openai:</a:t>
-            </a:r>
-            <a:endParaRPr lang="en-US" sz="1100" dirty="0"/>
+              <a:rPr lang="en-US" sz="950" dirty="0">
+                <a:solidFill>
+                  <a:srgbClr val="EFF7F5"/>
+                </a:solidFill>
+                <a:latin typeface="Courier New" pitchFamily="34" charset="0"/>
+                <a:ea typeface="Courier New" pitchFamily="34" charset="-122"/>
+                <a:cs typeface="Courier New" pitchFamily="34" charset="-120"/>
+              </a:rPr>
+              <a:t>spring.ai.openai.chat.completions-path=/v1beta/openai/chat/completions</a:t>
+            </a:r>
+            <a:endParaRPr lang="en-US" sz="950" dirty="0"/>
           </a:p>
           <a:p>
             <a:pPr indent="0" marL="0">
               <a:lnSpc>
-                <a:spcPts val="1400"/>
+                <a:spcPts val="1900"/>
               </a:lnSpc>
               <a:buNone/>
             </a:pPr>
             <a:r>
-              <a:rPr lang="en-US" sz="1100" dirty="0">
-                <a:solidFill>
-                  <a:srgbClr val="EFF7F5"/>
-                </a:solidFill>
-                <a:latin typeface="Courier New" pitchFamily="34" charset="0"/>
-                <a:ea typeface="Courier New" pitchFamily="34" charset="-122"/>
-                <a:cs typeface="Courier New" pitchFamily="34" charset="-120"/>
-              </a:rPr>
-              <a:t>      api-key: ${GEMINI_API_KEY:}</a:t>
-            </a:r>
-            <a:endParaRPr lang="en-US" sz="1100" dirty="0"/>
+              <a:rPr lang="en-US" sz="950" dirty="0">
+                <a:solidFill>
+                  <a:srgbClr val="EFF7F5"/>
+                </a:solidFill>
+                <a:latin typeface="Courier New" pitchFamily="34" charset="0"/>
+                <a:ea typeface="Courier New" pitchFamily="34" charset="-122"/>
+                <a:cs typeface="Courier New" pitchFamily="34" charset="-120"/>
+              </a:rPr>
+              <a:t>spring.ai.openai.chat.options.model=gemini-2.5-flash</a:t>
+            </a:r>
+            <a:endParaRPr lang="en-US" sz="950" dirty="0"/>
           </a:p>
           <a:p>
             <a:pPr indent="0" marL="0">
               <a:lnSpc>
-                <a:spcPts val="1400"/>
+                <a:spcPts val="1900"/>
               </a:lnSpc>
               <a:buNone/>
             </a:pPr>
             <a:r>
-              <a:rPr lang="en-US" sz="1100" dirty="0">
-                <a:solidFill>
-                  <a:srgbClr val="EFF7F5"/>
-                </a:solidFill>
-                <a:latin typeface="Courier New" pitchFamily="34" charset="0"/>
-                <a:ea typeface="Courier New" pitchFamily="34" charset="-122"/>
-                <a:cs typeface="Courier New" pitchFamily="34" charset="-120"/>
-              </a:rPr>
-              <a:t>      base-url: https://generativelanguage.googleapis.com</a:t>
-            </a:r>
-            <a:endParaRPr lang="en-US" sz="1100" dirty="0"/>
+              <a:rPr lang="en-US" sz="950" dirty="0">
+                <a:solidFill>
+                  <a:srgbClr val="EFF7F5"/>
+                </a:solidFill>
+                <a:latin typeface="Courier New" pitchFamily="34" charset="0"/>
+                <a:ea typeface="Courier New" pitchFamily="34" charset="-122"/>
+                <a:cs typeface="Courier New" pitchFamily="34" charset="-120"/>
+              </a:rPr>
+              <a:t>spring.ai.openai.embedding.embeddings-path=/v1beta/openai/embeddings</a:t>
+            </a:r>
+            <a:endParaRPr lang="en-US" sz="950" dirty="0"/>
           </a:p>
           <a:p>
             <a:pPr indent="0" marL="0">
               <a:lnSpc>
-                <a:spcPts val="1400"/>
+                <a:spcPts val="1900"/>
               </a:lnSpc>
               <a:buNone/>
             </a:pPr>
             <a:r>
-              <a:rPr lang="en-US" sz="1100" dirty="0">
-                <a:solidFill>
-                  <a:srgbClr val="EFF7F5"/>
-                </a:solidFill>
-                <a:latin typeface="Courier New" pitchFamily="34" charset="0"/>
-                <a:ea typeface="Courier New" pitchFamily="34" charset="-122"/>
-                <a:cs typeface="Courier New" pitchFamily="34" charset="-120"/>
-              </a:rPr>
-              <a:t>      chat:</a:t>
-            </a:r>
-            <a:endParaRPr lang="en-US" sz="1100" dirty="0"/>
-          </a:p>
-          <a:p>
-            <a:pPr indent="0" marL="0">
-              <a:lnSpc>
-                <a:spcPts val="1400"/>
-              </a:lnSpc>
-              <a:buNone/>
-            </a:pPr>
-            <a:r>
-              <a:rPr lang="en-US" sz="1100" dirty="0">
-                <a:solidFill>
-                  <a:srgbClr val="EFF7F5"/>
-                </a:solidFill>
-                <a:latin typeface="Courier New" pitchFamily="34" charset="0"/>
-                <a:ea typeface="Courier New" pitchFamily="34" charset="-122"/>
-                <a:cs typeface="Courier New" pitchFamily="34" charset="-120"/>
-              </a:rPr>
-              <a:t>        completions-path: /v1beta/openai/chat/completions</a:t>
-            </a:r>
-            <a:endParaRPr lang="en-US" sz="1100" dirty="0"/>
-          </a:p>
-          <a:p>
-            <a:pPr indent="0" marL="0">
-              <a:lnSpc>
-                <a:spcPts val="1400"/>
-              </a:lnSpc>
-              <a:buNone/>
-            </a:pPr>
-            <a:r>
-              <a:rPr lang="en-US" sz="1100" dirty="0">
-                <a:solidFill>
-                  <a:srgbClr val="EFF7F5"/>
-                </a:solidFill>
-                <a:latin typeface="Courier New" pitchFamily="34" charset="0"/>
-                <a:ea typeface="Courier New" pitchFamily="34" charset="-122"/>
-                <a:cs typeface="Courier New" pitchFamily="34" charset="-120"/>
-              </a:rPr>
-              <a:t>        options.model: gemini-2.5-flash</a:t>
-            </a:r>
-            <a:endParaRPr lang="en-US" sz="1100" dirty="0"/>
-          </a:p>
-          <a:p>
-            <a:pPr indent="0" marL="0">
-              <a:lnSpc>
-                <a:spcPts val="1400"/>
-              </a:lnSpc>
-              <a:buNone/>
-            </a:pPr>
-            <a:r>
-              <a:rPr lang="en-US" sz="1100" dirty="0">
-                <a:solidFill>
-                  <a:srgbClr val="EFF7F5"/>
-                </a:solidFill>
-                <a:latin typeface="Courier New" pitchFamily="34" charset="0"/>
-                <a:ea typeface="Courier New" pitchFamily="34" charset="-122"/>
-                <a:cs typeface="Courier New" pitchFamily="34" charset="-120"/>
-              </a:rPr>
-              <a:t>      embedding:</a:t>
-            </a:r>
-            <a:endParaRPr lang="en-US" sz="1100" dirty="0"/>
-          </a:p>
-          <a:p>
-            <a:pPr indent="0" marL="0">
-              <a:lnSpc>
-                <a:spcPts val="1400"/>
-              </a:lnSpc>
-              <a:buNone/>
-            </a:pPr>
-            <a:r>
-              <a:rPr lang="en-US" sz="1100" dirty="0">
-                <a:solidFill>
-                  <a:srgbClr val="EFF7F5"/>
-                </a:solidFill>
-                <a:latin typeface="Courier New" pitchFamily="34" charset="0"/>
-                <a:ea typeface="Courier New" pitchFamily="34" charset="-122"/>
-                <a:cs typeface="Courier New" pitchFamily="34" charset="-120"/>
-              </a:rPr>
-              <a:t>        embeddings-path: /v1beta/openai/embeddings</a:t>
-            </a:r>
-            <a:endParaRPr lang="en-US" sz="1100" dirty="0"/>
-          </a:p>
-          <a:p>
-            <a:pPr indent="0" marL="0">
-              <a:lnSpc>
-                <a:spcPts val="1400"/>
-              </a:lnSpc>
-              <a:buNone/>
-            </a:pPr>
-            <a:r>
-              <a:rPr lang="en-US" sz="1100" dirty="0">
-                <a:solidFill>
-                  <a:srgbClr val="EFF7F5"/>
-                </a:solidFill>
-                <a:latin typeface="Courier New" pitchFamily="34" charset="0"/>
-                <a:ea typeface="Courier New" pitchFamily="34" charset="-122"/>
-                <a:cs typeface="Courier New" pitchFamily="34" charset="-120"/>
-              </a:rPr>
-              <a:t>        options.model: gemini-embedding-001</a:t>
-            </a:r>
-            <a:endParaRPr lang="en-US" sz="1100" dirty="0"/>
+              <a:rPr lang="en-US" sz="950" dirty="0">
+                <a:solidFill>
+                  <a:srgbClr val="EFF7F5"/>
+                </a:solidFill>
+                <a:latin typeface="Courier New" pitchFamily="34" charset="0"/>
+                <a:ea typeface="Courier New" pitchFamily="34" charset="-122"/>
+                <a:cs typeface="Courier New" pitchFamily="34" charset="-120"/>
+              </a:rPr>
+              <a:t>spring.ai.openai.embedding.options.model=gemini-embedding-001</a:t>
+            </a:r>
+            <a:endParaRPr lang="en-US" sz="950" dirty="0"/>
           </a:p>
         </p:txBody>
       </p:sp>

</xml_diff>